<commit_message>
close both decks with the questions judges are likely to ask
</commit_message>
<xml_diff>
--- a/exports/Schwans_Five_Questions.pptx
+++ b/exports/Schwans_Five_Questions.pptx
@@ -14,9 +14,10 @@
     <p:sldId id="262" r:id="rId8"/>
     <p:sldId id="263" r:id="rId9"/>
     <p:sldId id="264" r:id="rId10"/>
+    <p:sldId id="265" r:id="rId11"/>
   </p:sldIdLst>
   <p:notesMasterIdLst>
-    <p:notesMasterId r:id="rId11"/>
+    <p:notesMasterId r:id="rId12"/>
   </p:notesMasterIdLst>
   <p:sldSz cx="18288000" cy="10287000"/>
   <p:notesSz cx="10287000" cy="18288000"/>
@@ -534,6 +535,94 @@
             <a:fld id="{F7021451-1387-4CA6-816F-3879F97B5CBC}" type="slidenum">
               <a:rPr lang="en-US"/>
               <a:t>1</a:t>
+            </a:fld>
+            <a:endParaRPr lang="en-US"/>
+          </a:p>
+        </p:txBody>
+      </p:sp>
+    </p:spTree>
+    <p:extLst>
+      <p:ext uri="{BB962C8B-B14F-4D97-AF65-F5344CB8AC3E}">
+        <p14:creationId xmlns:p14="http://schemas.microsoft.com/office/powerpoint/2010/main" val="1024086991"/>
+      </p:ext>
+    </p:extLst>
+  </p:cSld>
+  <p:clrMapOvr>
+    <a:masterClrMapping/>
+  </p:clrMapOvr>
+</p:notes>
+</file>
+
+<file path=ppt/notesSlides/notesSlide10.xml><?xml version="1.0" encoding="utf-8"?>
+<p:notes xmlns:a="http://schemas.openxmlformats.org/drawingml/2006/main" xmlns:r="http://schemas.openxmlformats.org/officeDocument/2006/relationships" xmlns:p="http://schemas.openxmlformats.org/presentationml/2006/main">
+  <p:cSld>
+    <p:spTree>
+      <p:nvGrpSpPr>
+        <p:cNvPr id="1" name=""/>
+        <p:cNvGrpSpPr/>
+        <p:nvPr/>
+      </p:nvGrpSpPr>
+      <p:grpSpPr>
+        <a:xfrm>
+          <a:off x="0" y="0"/>
+          <a:ext cx="0" cy="0"/>
+          <a:chOff x="0" y="0"/>
+          <a:chExt cx="0" cy="0"/>
+        </a:xfrm>
+      </p:grpSpPr>
+      <p:sp>
+        <p:nvSpPr>
+          <p:cNvPr id="2" name="Slide Image Placeholder 1"/>
+          <p:cNvSpPr>
+            <a:spLocks noGrp="1" noRot="1" noChangeAspect="1"/>
+          </p:cNvSpPr>
+          <p:nvPr>
+            <p:ph type="sldImg"/>
+          </p:nvPr>
+        </p:nvSpPr>
+        <p:spPr/>
+      </p:sp>
+      <p:sp>
+        <p:nvSpPr>
+          <p:cNvPr id="3" name="Notes Placeholder 2"/>
+          <p:cNvSpPr>
+            <a:spLocks noGrp="1"/>
+          </p:cNvSpPr>
+          <p:nvPr>
+            <p:ph type="body" idx="1"/>
+          </p:nvPr>
+        </p:nvSpPr>
+        <p:spPr/>
+        <p:txBody>
+          <a:bodyPr/>
+          <a:lstStyle/>
+          <a:p>
+            <a:r>
+              <a:rPr lang="en-US" dirty="0"/>
+              <a:t>If a question is not on this list, the honest answer is fine: I do not know, and I would rather find out than guess.</a:t>
+            </a:r>
+            <a:endParaRPr lang="en-US" dirty="0"/>
+          </a:p>
+        </p:txBody>
+      </p:sp>
+      <p:sp>
+        <p:nvSpPr>
+          <p:cNvPr id="4" name="Slide Number Placeholder 3"/>
+          <p:cNvSpPr>
+            <a:spLocks noGrp="1"/>
+          </p:cNvSpPr>
+          <p:nvPr>
+            <p:ph type="sldNum" sz="quarter" idx="10"/>
+          </p:nvPr>
+        </p:nvSpPr>
+        <p:spPr/>
+        <p:txBody>
+          <a:bodyPr/>
+          <a:lstStyle/>
+          <a:p>
+            <a:fld id="{F7021451-1387-4CA6-816F-3879F97B5CBC}" type="slidenum">
+              <a:rPr lang="en-US"/>
+              <a:t>10</a:t>
             </a:fld>
             <a:endParaRPr lang="en-US"/>
           </a:p>
@@ -1983,6 +2072,931 @@
 </p:sld>
 </file>
 
+<file path=ppt/slides/slide10.xml><?xml version="1.0" encoding="utf-8"?>
+<p:sld xmlns:a="http://schemas.openxmlformats.org/drawingml/2006/main" xmlns:r="http://schemas.openxmlformats.org/officeDocument/2006/relationships" xmlns:p="http://schemas.openxmlformats.org/presentationml/2006/main">
+  <p:cSld name="Slide 10">
+    <p:spTree>
+      <p:nvGrpSpPr>
+        <p:cNvPr id="1" name=""/>
+        <p:cNvGrpSpPr/>
+        <p:nvPr/>
+      </p:nvGrpSpPr>
+      <p:grpSpPr>
+        <a:xfrm>
+          <a:off x="0" y="0"/>
+          <a:ext cx="0" cy="0"/>
+          <a:chOff x="0" y="0"/>
+          <a:chExt cx="0" cy="0"/>
+        </a:xfrm>
+      </p:grpSpPr>
+      <p:sp>
+        <p:nvSpPr>
+          <p:cNvPr id="2" name="Shape 0"/>
+          <p:cNvSpPr/>
+          <p:nvPr/>
+        </p:nvSpPr>
+        <p:spPr>
+          <a:xfrm>
+            <a:off x="0" y="0"/>
+            <a:ext cx="18288000" cy="10287000"/>
+          </a:xfrm>
+          <a:prstGeom prst="rect">
+            <a:avLst/>
+          </a:prstGeom>
+          <a:solidFill>
+            <a:srgbClr val="FFFFFF"/>
+          </a:solidFill>
+          <a:ln w="12700">
+            <a:solidFill>
+              <a:srgbClr val="FFFFFF"/>
+            </a:solidFill>
+            <a:prstDash val="solid"/>
+          </a:ln>
+        </p:spPr>
+      </p:sp>
+      <p:sp>
+        <p:nvSpPr>
+          <p:cNvPr id="3" name="Text 1"/>
+          <p:cNvSpPr txBox="1"/>
+          <p:nvPr/>
+        </p:nvSpPr>
+        <p:spPr>
+          <a:xfrm>
+            <a:off x="1280160" y="914400"/>
+            <a:ext cx="7315200" cy="365760"/>
+          </a:xfrm>
+          <a:prstGeom prst="rect">
+            <a:avLst/>
+          </a:prstGeom>
+          <a:noFill/>
+          <a:ln/>
+        </p:spPr>
+        <p:txBody>
+          <a:bodyPr wrap="square" lIns="0" tIns="0" rIns="0" bIns="0" rtlCol="0" anchor="ctr"/>
+          <a:lstStyle/>
+          <a:p>
+            <a:pPr indent="0" marL="0">
+              <a:buNone/>
+            </a:pPr>
+            <a:r>
+              <a:rPr lang="en-US" sz="1300" b="1" spc="300" kern="0" dirty="0">
+                <a:solidFill>
+                  <a:srgbClr val="6E7788"/>
+                </a:solidFill>
+                <a:latin typeface="Calibri" pitchFamily="34" charset="0"/>
+                <a:ea typeface="Calibri" pitchFamily="34" charset="-122"/>
+                <a:cs typeface="Calibri" pitchFamily="34" charset="-120"/>
+              </a:rPr>
+              <a:t>QUESTIONS TO EXPECT</a:t>
+            </a:r>
+            <a:endParaRPr lang="en-US" sz="1300" dirty="0"/>
+          </a:p>
+        </p:txBody>
+      </p:sp>
+      <p:sp>
+        <p:nvSpPr>
+          <p:cNvPr id="4" name="Text 2"/>
+          <p:cNvSpPr txBox="1"/>
+          <p:nvPr/>
+        </p:nvSpPr>
+        <p:spPr>
+          <a:xfrm>
+            <a:off x="1280160" y="1325880"/>
+            <a:ext cx="12801600" cy="1737360"/>
+          </a:xfrm>
+          <a:prstGeom prst="rect">
+            <a:avLst/>
+          </a:prstGeom>
+          <a:noFill/>
+          <a:ln/>
+        </p:spPr>
+        <p:txBody>
+          <a:bodyPr wrap="square" lIns="0" tIns="0" rIns="0" bIns="0" rtlCol="0" anchor="ctr"/>
+          <a:lstStyle/>
+          <a:p>
+            <a:pPr indent="0" marL="0">
+              <a:lnSpc>
+                <a:spcPct val="106000"/>
+              </a:lnSpc>
+              <a:buNone/>
+            </a:pPr>
+            <a:r>
+              <a:rPr lang="en-US" sz="4200" dirty="0">
+                <a:solidFill>
+                  <a:srgbClr val="232E54"/>
+                </a:solidFill>
+                <a:latin typeface="Bahnschrift SemiBold" pitchFamily="34" charset="0"/>
+                <a:ea typeface="Bahnschrift SemiBold" pitchFamily="34" charset="-122"/>
+                <a:cs typeface="Bahnschrift SemiBold" pitchFamily="34" charset="-120"/>
+              </a:rPr>
+              <a:t>Ask me any of these.</a:t>
+            </a:r>
+            <a:endParaRPr lang="en-US" sz="4200" dirty="0"/>
+          </a:p>
+        </p:txBody>
+      </p:sp>
+      <p:sp>
+        <p:nvSpPr>
+          <p:cNvPr id="5" name="Text 3"/>
+          <p:cNvSpPr txBox="1"/>
+          <p:nvPr/>
+        </p:nvSpPr>
+        <p:spPr>
+          <a:xfrm>
+            <a:off x="1280160" y="3566160"/>
+            <a:ext cx="6858000" cy="594360"/>
+          </a:xfrm>
+          <a:prstGeom prst="rect">
+            <a:avLst/>
+          </a:prstGeom>
+          <a:noFill/>
+          <a:ln/>
+        </p:spPr>
+        <p:txBody>
+          <a:bodyPr wrap="square" lIns="0" tIns="0" rIns="0" bIns="0" rtlCol="0" anchor="ctr"/>
+          <a:lstStyle/>
+          <a:p>
+            <a:pPr indent="0" marL="0">
+              <a:lnSpc>
+                <a:spcPct val="112000"/>
+              </a:lnSpc>
+              <a:buNone/>
+            </a:pPr>
+            <a:r>
+              <a:rPr lang="en-US" sz="2000" dirty="0">
+                <a:solidFill>
+                  <a:srgbClr val="232E54"/>
+                </a:solidFill>
+                <a:latin typeface="Bahnschrift SemiBold" pitchFamily="34" charset="0"/>
+                <a:ea typeface="Bahnschrift SemiBold" pitchFamily="34" charset="-122"/>
+                <a:cs typeface="Bahnschrift SemiBold" pitchFamily="34" charset="-120"/>
+              </a:rPr>
+              <a:t>Are these real Schwan's numbers?</a:t>
+            </a:r>
+            <a:endParaRPr lang="en-US" sz="2000" dirty="0"/>
+          </a:p>
+        </p:txBody>
+      </p:sp>
+      <p:sp>
+        <p:nvSpPr>
+          <p:cNvPr id="6" name="Text 4"/>
+          <p:cNvSpPr txBox="1"/>
+          <p:nvPr/>
+        </p:nvSpPr>
+        <p:spPr>
+          <a:xfrm>
+            <a:off x="1280160" y="4206240"/>
+            <a:ext cx="6858000" cy="868680"/>
+          </a:xfrm>
+          <a:prstGeom prst="rect">
+            <a:avLst/>
+          </a:prstGeom>
+          <a:noFill/>
+          <a:ln/>
+        </p:spPr>
+        <p:txBody>
+          <a:bodyPr wrap="square" lIns="0" tIns="0" rIns="0" bIns="0" rtlCol="0" anchor="ctr"/>
+          <a:lstStyle/>
+          <a:p>
+            <a:pPr indent="0" marL="0">
+              <a:lnSpc>
+                <a:spcPct val="130000"/>
+              </a:lnSpc>
+              <a:buNone/>
+            </a:pPr>
+            <a:r>
+              <a:rPr lang="en-US" sz="1600" dirty="0">
+                <a:solidFill>
+                  <a:srgbClr val="6E7788"/>
+                </a:solidFill>
+                <a:latin typeface="Calibri" pitchFamily="34" charset="0"/>
+                <a:ea typeface="Calibri" pitchFamily="34" charset="-122"/>
+                <a:cs typeface="Calibri" pitchFamily="34" charset="-120"/>
+              </a:rPr>
+              <a:t>No. Coverage and headcounts are demo data. Locations, job groups and the regulations are sourced.</a:t>
+            </a:r>
+            <a:endParaRPr lang="en-US" sz="1600" dirty="0"/>
+          </a:p>
+        </p:txBody>
+      </p:sp>
+      <p:sp>
+        <p:nvSpPr>
+          <p:cNvPr id="7" name="Shape 5"/>
+          <p:cNvSpPr/>
+          <p:nvPr/>
+        </p:nvSpPr>
+        <p:spPr>
+          <a:xfrm>
+            <a:off x="8595360" y="3429000"/>
+            <a:ext cx="0" cy="1554480"/>
+          </a:xfrm>
+          <a:prstGeom prst="line">
+            <a:avLst/>
+          </a:prstGeom>
+          <a:noFill/>
+          <a:ln w="12700">
+            <a:solidFill>
+              <a:srgbClr val="D9D9D9"/>
+            </a:solidFill>
+            <a:prstDash val="solid"/>
+          </a:ln>
+        </p:spPr>
+      </p:sp>
+      <p:sp>
+        <p:nvSpPr>
+          <p:cNvPr id="8" name="Shape 6"/>
+          <p:cNvSpPr/>
+          <p:nvPr/>
+        </p:nvSpPr>
+        <p:spPr>
+          <a:xfrm>
+            <a:off x="1280160" y="5193792"/>
+            <a:ext cx="6858000" cy="0"/>
+          </a:xfrm>
+          <a:prstGeom prst="line">
+            <a:avLst/>
+          </a:prstGeom>
+          <a:noFill/>
+          <a:ln w="12700">
+            <a:solidFill>
+              <a:srgbClr val="D9D9D9"/>
+            </a:solidFill>
+            <a:prstDash val="solid"/>
+          </a:ln>
+        </p:spPr>
+      </p:sp>
+      <p:sp>
+        <p:nvSpPr>
+          <p:cNvPr id="9" name="Text 7"/>
+          <p:cNvSpPr txBox="1"/>
+          <p:nvPr/>
+        </p:nvSpPr>
+        <p:spPr>
+          <a:xfrm>
+            <a:off x="9235440" y="3566160"/>
+            <a:ext cx="6858000" cy="594360"/>
+          </a:xfrm>
+          <a:prstGeom prst="rect">
+            <a:avLst/>
+          </a:prstGeom>
+          <a:noFill/>
+          <a:ln/>
+        </p:spPr>
+        <p:txBody>
+          <a:bodyPr wrap="square" lIns="0" tIns="0" rIns="0" bIns="0" rtlCol="0" anchor="ctr"/>
+          <a:lstStyle/>
+          <a:p>
+            <a:pPr indent="0" marL="0">
+              <a:lnSpc>
+                <a:spcPct val="112000"/>
+              </a:lnSpc>
+              <a:buNone/>
+            </a:pPr>
+            <a:r>
+              <a:rPr lang="en-US" sz="2000" dirty="0">
+                <a:solidFill>
+                  <a:srgbClr val="232E54"/>
+                </a:solidFill>
+                <a:latin typeface="Bahnschrift SemiBold" pitchFamily="34" charset="0"/>
+                <a:ea typeface="Bahnschrift SemiBold" pitchFamily="34" charset="-122"/>
+                <a:cs typeface="Bahnschrift SemiBold" pitchFamily="34" charset="-120"/>
+              </a:rPr>
+              <a:t>Where would this data really come from?</a:t>
+            </a:r>
+            <a:endParaRPr lang="en-US" sz="2000" dirty="0"/>
+          </a:p>
+        </p:txBody>
+      </p:sp>
+      <p:sp>
+        <p:nvSpPr>
+          <p:cNvPr id="10" name="Text 8"/>
+          <p:cNvSpPr txBox="1"/>
+          <p:nvPr/>
+        </p:nvSpPr>
+        <p:spPr>
+          <a:xfrm>
+            <a:off x="9235440" y="4206240"/>
+            <a:ext cx="6858000" cy="868680"/>
+          </a:xfrm>
+          <a:prstGeom prst="rect">
+            <a:avLst/>
+          </a:prstGeom>
+          <a:noFill/>
+          <a:ln/>
+        </p:spPr>
+        <p:txBody>
+          <a:bodyPr wrap="square" lIns="0" tIns="0" rIns="0" bIns="0" rtlCol="0" anchor="ctr"/>
+          <a:lstStyle/>
+          <a:p>
+            <a:pPr indent="0" marL="0">
+              <a:lnSpc>
+                <a:spcPct val="130000"/>
+              </a:lnSpc>
+              <a:buNone/>
+            </a:pPr>
+            <a:r>
+              <a:rPr lang="en-US" sz="1600" dirty="0">
+                <a:solidFill>
+                  <a:srgbClr val="6E7788"/>
+                </a:solidFill>
+                <a:latin typeface="Calibri" pitchFamily="34" charset="0"/>
+                <a:ea typeface="Calibri" pitchFamily="34" charset="-122"/>
+                <a:cs typeface="Calibri" pitchFamily="34" charset="-120"/>
+              </a:rPr>
+              <a:t>Training and certification records, maintenance sign-offs, HR job codes. OSHA keeps the ammonia roster by law.</a:t>
+            </a:r>
+            <a:endParaRPr lang="en-US" sz="1600" dirty="0"/>
+          </a:p>
+        </p:txBody>
+      </p:sp>
+      <p:sp>
+        <p:nvSpPr>
+          <p:cNvPr id="11" name="Shape 9"/>
+          <p:cNvSpPr/>
+          <p:nvPr/>
+        </p:nvSpPr>
+        <p:spPr>
+          <a:xfrm>
+            <a:off x="9235440" y="5193792"/>
+            <a:ext cx="6858000" cy="0"/>
+          </a:xfrm>
+          <a:prstGeom prst="line">
+            <a:avLst/>
+          </a:prstGeom>
+          <a:noFill/>
+          <a:ln w="12700">
+            <a:solidFill>
+              <a:srgbClr val="D9D9D9"/>
+            </a:solidFill>
+            <a:prstDash val="solid"/>
+          </a:ln>
+        </p:spPr>
+      </p:sp>
+      <p:sp>
+        <p:nvSpPr>
+          <p:cNvPr id="12" name="Text 10"/>
+          <p:cNvSpPr txBox="1"/>
+          <p:nvPr/>
+        </p:nvSpPr>
+        <p:spPr>
+          <a:xfrm>
+            <a:off x="1280160" y="5394960"/>
+            <a:ext cx="6858000" cy="594360"/>
+          </a:xfrm>
+          <a:prstGeom prst="rect">
+            <a:avLst/>
+          </a:prstGeom>
+          <a:noFill/>
+          <a:ln/>
+        </p:spPr>
+        <p:txBody>
+          <a:bodyPr wrap="square" lIns="0" tIns="0" rIns="0" bIns="0" rtlCol="0" anchor="ctr"/>
+          <a:lstStyle/>
+          <a:p>
+            <a:pPr indent="0" marL="0">
+              <a:lnSpc>
+                <a:spcPct val="112000"/>
+              </a:lnSpc>
+              <a:buNone/>
+            </a:pPr>
+            <a:r>
+              <a:rPr lang="en-US" sz="2000" dirty="0">
+                <a:solidFill>
+                  <a:srgbClr val="232E54"/>
+                </a:solidFill>
+                <a:latin typeface="Bahnschrift SemiBold" pitchFamily="34" charset="0"/>
+                <a:ea typeface="Bahnschrift SemiBold" pitchFamily="34" charset="-122"/>
+                <a:cs typeface="Bahnschrift SemiBold" pitchFamily="34" charset="-120"/>
+              </a:rPr>
+              <a:t>How is the ranking calculated?</a:t>
+            </a:r>
+            <a:endParaRPr lang="en-US" sz="2000" dirty="0"/>
+          </a:p>
+        </p:txBody>
+      </p:sp>
+      <p:sp>
+        <p:nvSpPr>
+          <p:cNvPr id="13" name="Text 11"/>
+          <p:cNvSpPr txBox="1"/>
+          <p:nvPr/>
+        </p:nvSpPr>
+        <p:spPr>
+          <a:xfrm>
+            <a:off x="1280160" y="6035040"/>
+            <a:ext cx="6858000" cy="868680"/>
+          </a:xfrm>
+          <a:prstGeom prst="rect">
+            <a:avLst/>
+          </a:prstGeom>
+          <a:noFill/>
+          <a:ln/>
+        </p:spPr>
+        <p:txBody>
+          <a:bodyPr wrap="square" lIns="0" tIns="0" rIns="0" bIns="0" rtlCol="0" anchor="ctr"/>
+          <a:lstStyle/>
+          <a:p>
+            <a:pPr indent="0" marL="0">
+              <a:lnSpc>
+                <a:spcPct val="130000"/>
+              </a:lnSpc>
+              <a:buNone/>
+            </a:pPr>
+            <a:r>
+              <a:rPr lang="en-US" sz="1600" dirty="0">
+                <a:solidFill>
+                  <a:srgbClr val="6E7788"/>
+                </a:solidFill>
+                <a:latin typeface="Calibri" pitchFamily="34" charset="0"/>
+                <a:ea typeface="Calibri" pitchFamily="34" charset="-122"/>
+                <a:cs typeface="Calibri" pitchFamily="34" charset="-120"/>
+              </a:rPr>
+              <a:t>Impact out of five, times three over the number of holders, times the size of the gap. Shown on screen.</a:t>
+            </a:r>
+            <a:endParaRPr lang="en-US" sz="1600" dirty="0"/>
+          </a:p>
+        </p:txBody>
+      </p:sp>
+      <p:sp>
+        <p:nvSpPr>
+          <p:cNvPr id="14" name="Shape 12"/>
+          <p:cNvSpPr/>
+          <p:nvPr/>
+        </p:nvSpPr>
+        <p:spPr>
+          <a:xfrm>
+            <a:off x="8595360" y="5257800"/>
+            <a:ext cx="0" cy="1554480"/>
+          </a:xfrm>
+          <a:prstGeom prst="line">
+            <a:avLst/>
+          </a:prstGeom>
+          <a:noFill/>
+          <a:ln w="12700">
+            <a:solidFill>
+              <a:srgbClr val="D9D9D9"/>
+            </a:solidFill>
+            <a:prstDash val="solid"/>
+          </a:ln>
+        </p:spPr>
+      </p:sp>
+      <p:sp>
+        <p:nvSpPr>
+          <p:cNvPr id="15" name="Shape 13"/>
+          <p:cNvSpPr/>
+          <p:nvPr/>
+        </p:nvSpPr>
+        <p:spPr>
+          <a:xfrm>
+            <a:off x="1280160" y="7022592"/>
+            <a:ext cx="6858000" cy="0"/>
+          </a:xfrm>
+          <a:prstGeom prst="line">
+            <a:avLst/>
+          </a:prstGeom>
+          <a:noFill/>
+          <a:ln w="12700">
+            <a:solidFill>
+              <a:srgbClr val="D9D9D9"/>
+            </a:solidFill>
+            <a:prstDash val="solid"/>
+          </a:ln>
+        </p:spPr>
+      </p:sp>
+      <p:sp>
+        <p:nvSpPr>
+          <p:cNvPr id="16" name="Text 14"/>
+          <p:cNvSpPr txBox="1"/>
+          <p:nvPr/>
+        </p:nvSpPr>
+        <p:spPr>
+          <a:xfrm>
+            <a:off x="9235440" y="5394960"/>
+            <a:ext cx="6858000" cy="594360"/>
+          </a:xfrm>
+          <a:prstGeom prst="rect">
+            <a:avLst/>
+          </a:prstGeom>
+          <a:noFill/>
+          <a:ln/>
+        </p:spPr>
+        <p:txBody>
+          <a:bodyPr wrap="square" lIns="0" tIns="0" rIns="0" bIns="0" rtlCol="0" anchor="ctr"/>
+          <a:lstStyle/>
+          <a:p>
+            <a:pPr indent="0" marL="0">
+              <a:lnSpc>
+                <a:spcPct val="112000"/>
+              </a:lnSpc>
+              <a:buNone/>
+            </a:pPr>
+            <a:r>
+              <a:rPr lang="en-US" sz="2000" dirty="0">
+                <a:solidFill>
+                  <a:srgbClr val="232E54"/>
+                </a:solidFill>
+                <a:latin typeface="Bahnschrift SemiBold" pitchFamily="34" charset="0"/>
+                <a:ea typeface="Bahnschrift SemiBold" pitchFamily="34" charset="-122"/>
+                <a:cs typeface="Bahnschrift SemiBold" pitchFamily="34" charset="-120"/>
+              </a:rPr>
+              <a:t>Why is there no AI advisor?</a:t>
+            </a:r>
+            <a:endParaRPr lang="en-US" sz="2000" dirty="0"/>
+          </a:p>
+        </p:txBody>
+      </p:sp>
+      <p:sp>
+        <p:nvSpPr>
+          <p:cNvPr id="17" name="Text 15"/>
+          <p:cNvSpPr txBox="1"/>
+          <p:nvPr/>
+        </p:nvSpPr>
+        <p:spPr>
+          <a:xfrm>
+            <a:off x="9235440" y="6035040"/>
+            <a:ext cx="6858000" cy="868680"/>
+          </a:xfrm>
+          <a:prstGeom prst="rect">
+            <a:avLst/>
+          </a:prstGeom>
+          <a:noFill/>
+          <a:ln/>
+        </p:spPr>
+        <p:txBody>
+          <a:bodyPr wrap="square" lIns="0" tIns="0" rIns="0" bIns="0" rtlCol="0" anchor="ctr"/>
+          <a:lstStyle/>
+          <a:p>
+            <a:pPr indent="0" marL="0">
+              <a:lnSpc>
+                <a:spcPct val="130000"/>
+              </a:lnSpc>
+              <a:buNone/>
+            </a:pPr>
+            <a:r>
+              <a:rPr lang="en-US" sz="1600" dirty="0">
+                <a:solidFill>
+                  <a:srgbClr val="6E7788"/>
+                </a:solidFill>
+                <a:latin typeface="Calibri" pitchFamily="34" charset="0"/>
+                <a:ea typeface="Calibri" pitchFamily="34" charset="-122"/>
+                <a:cs typeface="Calibri" pitchFamily="34" charset="-120"/>
+              </a:rPr>
+              <a:t>The prompt lists it as one option of seven. A chatbot over twenty seeded rows would have been a bluff.</a:t>
+            </a:r>
+            <a:endParaRPr lang="en-US" sz="1600" dirty="0"/>
+          </a:p>
+        </p:txBody>
+      </p:sp>
+      <p:sp>
+        <p:nvSpPr>
+          <p:cNvPr id="18" name="Shape 16"/>
+          <p:cNvSpPr/>
+          <p:nvPr/>
+        </p:nvSpPr>
+        <p:spPr>
+          <a:xfrm>
+            <a:off x="9235440" y="7022592"/>
+            <a:ext cx="6858000" cy="0"/>
+          </a:xfrm>
+          <a:prstGeom prst="line">
+            <a:avLst/>
+          </a:prstGeom>
+          <a:noFill/>
+          <a:ln w="12700">
+            <a:solidFill>
+              <a:srgbClr val="D9D9D9"/>
+            </a:solidFill>
+            <a:prstDash val="solid"/>
+          </a:ln>
+        </p:spPr>
+      </p:sp>
+      <p:sp>
+        <p:nvSpPr>
+          <p:cNvPr id="19" name="Text 17"/>
+          <p:cNvSpPr txBox="1"/>
+          <p:nvPr/>
+        </p:nvSpPr>
+        <p:spPr>
+          <a:xfrm>
+            <a:off x="1280160" y="7223760"/>
+            <a:ext cx="6858000" cy="594360"/>
+          </a:xfrm>
+          <a:prstGeom prst="rect">
+            <a:avLst/>
+          </a:prstGeom>
+          <a:noFill/>
+          <a:ln/>
+        </p:spPr>
+        <p:txBody>
+          <a:bodyPr wrap="square" lIns="0" tIns="0" rIns="0" bIns="0" rtlCol="0" anchor="ctr"/>
+          <a:lstStyle/>
+          <a:p>
+            <a:pPr indent="0" marL="0">
+              <a:lnSpc>
+                <a:spcPct val="112000"/>
+              </a:lnSpc>
+              <a:buNone/>
+            </a:pPr>
+            <a:r>
+              <a:rPr lang="en-US" sz="2000" dirty="0">
+                <a:solidFill>
+                  <a:srgbClr val="232E54"/>
+                </a:solidFill>
+                <a:latin typeface="Bahnschrift SemiBold" pitchFamily="34" charset="0"/>
+                <a:ea typeface="Bahnschrift SemiBold" pitchFamily="34" charset="-122"/>
+                <a:cs typeface="Bahnschrift SemiBold" pitchFamily="34" charset="-120"/>
+              </a:rPr>
+              <a:t>Why only three employee profiles?</a:t>
+            </a:r>
+            <a:endParaRPr lang="en-US" sz="2000" dirty="0"/>
+          </a:p>
+        </p:txBody>
+      </p:sp>
+      <p:sp>
+        <p:nvSpPr>
+          <p:cNvPr id="20" name="Text 18"/>
+          <p:cNvSpPr txBox="1"/>
+          <p:nvPr/>
+        </p:nvSpPr>
+        <p:spPr>
+          <a:xfrm>
+            <a:off x="1280160" y="7863840"/>
+            <a:ext cx="6858000" cy="868680"/>
+          </a:xfrm>
+          <a:prstGeom prst="rect">
+            <a:avLst/>
+          </a:prstGeom>
+          <a:noFill/>
+          <a:ln/>
+        </p:spPr>
+        <p:txBody>
+          <a:bodyPr wrap="square" lIns="0" tIns="0" rIns="0" bIns="0" rtlCol="0" anchor="ctr"/>
+          <a:lstStyle/>
+          <a:p>
+            <a:pPr indent="0" marL="0">
+              <a:lnSpc>
+                <a:spcPct val="130000"/>
+              </a:lnSpc>
+              <a:buNone/>
+            </a:pPr>
+            <a:r>
+              <a:rPr lang="en-US" sz="1600" dirty="0">
+                <a:solidFill>
+                  <a:srgbClr val="6E7788"/>
+                </a:solidFill>
+                <a:latin typeface="Calibri" pitchFamily="34" charset="0"/>
+                <a:ea typeface="Calibri" pitchFamily="34" charset="-122"/>
+                <a:cs typeface="Calibri" pitchFamily="34" charset="-120"/>
+              </a:rPr>
+              <a:t>They are samples. The view reads whatever roster it is given, and the plan state is shared with the manager.</a:t>
+            </a:r>
+            <a:endParaRPr lang="en-US" sz="1600" dirty="0"/>
+          </a:p>
+        </p:txBody>
+      </p:sp>
+      <p:sp>
+        <p:nvSpPr>
+          <p:cNvPr id="21" name="Shape 19"/>
+          <p:cNvSpPr/>
+          <p:nvPr/>
+        </p:nvSpPr>
+        <p:spPr>
+          <a:xfrm>
+            <a:off x="8595360" y="7086600"/>
+            <a:ext cx="0" cy="1554480"/>
+          </a:xfrm>
+          <a:prstGeom prst="line">
+            <a:avLst/>
+          </a:prstGeom>
+          <a:noFill/>
+          <a:ln w="12700">
+            <a:solidFill>
+              <a:srgbClr val="D9D9D9"/>
+            </a:solidFill>
+            <a:prstDash val="solid"/>
+          </a:ln>
+        </p:spPr>
+      </p:sp>
+      <p:sp>
+        <p:nvSpPr>
+          <p:cNvPr id="22" name="Text 20"/>
+          <p:cNvSpPr txBox="1"/>
+          <p:nvPr/>
+        </p:nvSpPr>
+        <p:spPr>
+          <a:xfrm>
+            <a:off x="9235440" y="7223760"/>
+            <a:ext cx="6858000" cy="594360"/>
+          </a:xfrm>
+          <a:prstGeom prst="rect">
+            <a:avLst/>
+          </a:prstGeom>
+          <a:noFill/>
+          <a:ln/>
+        </p:spPr>
+        <p:txBody>
+          <a:bodyPr wrap="square" lIns="0" tIns="0" rIns="0" bIns="0" rtlCol="0" anchor="ctr"/>
+          <a:lstStyle/>
+          <a:p>
+            <a:pPr indent="0" marL="0">
+              <a:lnSpc>
+                <a:spcPct val="112000"/>
+              </a:lnSpc>
+              <a:buNone/>
+            </a:pPr>
+            <a:r>
+              <a:rPr lang="en-US" sz="2000" dirty="0">
+                <a:solidFill>
+                  <a:srgbClr val="232E54"/>
+                </a:solidFill>
+                <a:latin typeface="Bahnschrift SemiBold" pitchFamily="34" charset="0"/>
+                <a:ea typeface="Bahnschrift SemiBold" pitchFamily="34" charset="-122"/>
+                <a:cs typeface="Bahnschrift SemiBold" pitchFamily="34" charset="-120"/>
+              </a:rPr>
+              <a:t>What would you build next?</a:t>
+            </a:r>
+            <a:endParaRPr lang="en-US" sz="2000" dirty="0"/>
+          </a:p>
+        </p:txBody>
+      </p:sp>
+      <p:sp>
+        <p:nvSpPr>
+          <p:cNvPr id="23" name="Text 21"/>
+          <p:cNvSpPr txBox="1"/>
+          <p:nvPr/>
+        </p:nvSpPr>
+        <p:spPr>
+          <a:xfrm>
+            <a:off x="9235440" y="7863840"/>
+            <a:ext cx="6858000" cy="868680"/>
+          </a:xfrm>
+          <a:prstGeom prst="rect">
+            <a:avLst/>
+          </a:prstGeom>
+          <a:noFill/>
+          <a:ln/>
+        </p:spPr>
+        <p:txBody>
+          <a:bodyPr wrap="square" lIns="0" tIns="0" rIns="0" bIns="0" rtlCol="0" anchor="ctr"/>
+          <a:lstStyle/>
+          <a:p>
+            <a:pPr indent="0" marL="0">
+              <a:lnSpc>
+                <a:spcPct val="130000"/>
+              </a:lnSpc>
+              <a:buNone/>
+            </a:pPr>
+            <a:r>
+              <a:rPr lang="en-US" sz="1600" dirty="0">
+                <a:solidFill>
+                  <a:srgbClr val="6E7788"/>
+                </a:solidFill>
+                <a:latin typeface="Calibri" pitchFamily="34" charset="0"/>
+                <a:ea typeface="Calibri" pitchFamily="34" charset="-122"/>
+                <a:cs typeface="Calibri" pitchFamily="34" charset="-120"/>
+              </a:rPr>
+              <a:t>Live HR data, plans matched to people automatically, and a manager's view of one team rather than the company.</a:t>
+            </a:r>
+            <a:endParaRPr lang="en-US" sz="1600" dirty="0"/>
+          </a:p>
+        </p:txBody>
+      </p:sp>
+      <p:sp>
+        <p:nvSpPr>
+          <p:cNvPr id="24" name="Shape 22"/>
+          <p:cNvSpPr/>
+          <p:nvPr/>
+        </p:nvSpPr>
+        <p:spPr>
+          <a:xfrm>
+            <a:off x="1280160" y="9189720"/>
+            <a:ext cx="15727680" cy="0"/>
+          </a:xfrm>
+          <a:prstGeom prst="line">
+            <a:avLst/>
+          </a:prstGeom>
+          <a:noFill/>
+          <a:ln w="12700">
+            <a:solidFill>
+              <a:srgbClr val="D9D9D9"/>
+            </a:solidFill>
+            <a:prstDash val="solid"/>
+          </a:ln>
+        </p:spPr>
+      </p:sp>
+      <p:sp>
+        <p:nvSpPr>
+          <p:cNvPr id="25" name="Text 23"/>
+          <p:cNvSpPr txBox="1"/>
+          <p:nvPr/>
+        </p:nvSpPr>
+        <p:spPr>
+          <a:xfrm>
+            <a:off x="1280160" y="9372600"/>
+            <a:ext cx="8138160" cy="411480"/>
+          </a:xfrm>
+          <a:prstGeom prst="rect">
+            <a:avLst/>
+          </a:prstGeom>
+          <a:noFill/>
+          <a:ln/>
+        </p:spPr>
+        <p:txBody>
+          <a:bodyPr wrap="square" lIns="0" tIns="0" rIns="0" bIns="0" rtlCol="0" anchor="ctr"/>
+          <a:lstStyle/>
+          <a:p>
+            <a:pPr indent="0" marL="0">
+              <a:buNone/>
+            </a:pPr>
+            <a:r>
+              <a:rPr lang="en-US" sz="1400" b="1" spc="200" kern="0" dirty="0">
+                <a:solidFill>
+                  <a:srgbClr val="6E7788"/>
+                </a:solidFill>
+                <a:latin typeface="Calibri" pitchFamily="34" charset="0"/>
+                <a:ea typeface="Calibri" pitchFamily="34" charset="-122"/>
+                <a:cs typeface="Calibri" pitchFamily="34" charset="-120"/>
+              </a:rPr>
+              <a:t>IN THE APP   </a:t>
+            </a:r>
+            <a:pPr indent="0" marL="0">
+              <a:buNone/>
+            </a:pPr>
+            <a:r>
+              <a:rPr lang="en-US" sz="1400" dirty="0">
+                <a:solidFill>
+                  <a:srgbClr val="18212F"/>
+                </a:solidFill>
+                <a:latin typeface="Calibri" pitchFamily="34" charset="0"/>
+                <a:ea typeface="Calibri" pitchFamily="34" charset="-122"/>
+                <a:cs typeface="Calibri" pitchFamily="34" charset="-120"/>
+              </a:rPr>
+              <a:t>Q&amp;A.html in the repository has the full sheet</a:t>
+            </a:r>
+            <a:endParaRPr lang="en-US" sz="1400" dirty="0"/>
+          </a:p>
+        </p:txBody>
+      </p:sp>
+      <p:sp>
+        <p:nvSpPr>
+          <p:cNvPr id="26" name="Text 24"/>
+          <p:cNvSpPr txBox="1"/>
+          <p:nvPr/>
+        </p:nvSpPr>
+        <p:spPr>
+          <a:xfrm>
+            <a:off x="9418320" y="9372600"/>
+            <a:ext cx="7589520" cy="411480"/>
+          </a:xfrm>
+          <a:prstGeom prst="rect">
+            <a:avLst/>
+          </a:prstGeom>
+          <a:noFill/>
+          <a:ln/>
+        </p:spPr>
+        <p:txBody>
+          <a:bodyPr wrap="square" lIns="0" tIns="0" rIns="0" bIns="0" rtlCol="0" anchor="ctr"/>
+          <a:lstStyle/>
+          <a:p>
+            <a:pPr indent="0" marL="0">
+              <a:buNone/>
+            </a:pPr>
+            <a:r>
+              <a:rPr lang="en-US" sz="1400" b="1" spc="200" kern="0" dirty="0">
+                <a:solidFill>
+                  <a:srgbClr val="6E7788"/>
+                </a:solidFill>
+                <a:latin typeface="Calibri" pitchFamily="34" charset="0"/>
+                <a:ea typeface="Calibri" pitchFamily="34" charset="-122"/>
+                <a:cs typeface="Calibri" pitchFamily="34" charset="-120"/>
+              </a:rPr>
+              <a:t>NUMBERS FROM   </a:t>
+            </a:r>
+            <a:pPr indent="0" marL="0">
+              <a:buNone/>
+            </a:pPr>
+            <a:r>
+              <a:rPr lang="en-US" sz="1400" dirty="0">
+                <a:solidFill>
+                  <a:srgbClr val="18212F"/>
+                </a:solidFill>
+                <a:latin typeface="Calibri" pitchFamily="34" charset="0"/>
+                <a:ea typeface="Calibri" pitchFamily="34" charset="-122"/>
+                <a:cs typeface="Calibri" pitchFamily="34" charset="-120"/>
+              </a:rPr>
+              <a:t>FACTS.md lists every claim, its source, and what was cut</a:t>
+            </a:r>
+            <a:endParaRPr lang="en-US" sz="1400" dirty="0"/>
+          </a:p>
+        </p:txBody>
+      </p:sp>
+    </p:spTree>
+  </p:cSld>
+  <p:clrMapOvr>
+    <a:masterClrMapping/>
+  </p:clrMapOvr>
+</p:sld>
+</file>
+
 <file path=ppt/slides/slide2.xml><?xml version="1.0" encoding="utf-8"?>
 <p:sld xmlns:a="http://schemas.openxmlformats.org/drawingml/2006/main" xmlns:r="http://schemas.openxmlformats.org/officeDocument/2006/relationships" xmlns:p="http://schemas.openxmlformats.org/presentationml/2006/main">
   <p:cSld name="Slide 2">

</xml_diff>